<commit_message>
Sharpen Maestro refund case scenario
</commit_message>
<xml_diff>
--- a/docs/CaseProof_AI_AgentHack_Deck_Draft.pptx
+++ b/docs/CaseProof_AI_AgentHack_Deck_Draft.pptx
@@ -3151,7 +3151,7 @@
               <a:defRPr sz="1700"/>
             </a:pPr>
             <a:r>
-              <a:t>A human-review gate for AI-handled UiPath Maestro cases.</a:t>
+              <a:t>A human-review gate for high-value refund exception cases.</a:t>
             </a:r>
           </a:p>
         </p:txBody>
@@ -3185,7 +3185,7 @@
               <a:defRPr sz="2300"/>
             </a:pPr>
             <a:r>
-              <a:t>Agents can prepare cases, but they should not silently approve risky cases.</a:t>
+              <a:t>Agents can prepare refund cases, but preparation is not approval.</a:t>
             </a:r>
           </a:p>
           <a:p>
@@ -3196,7 +3196,7 @@
               <a:defRPr sz="2300"/>
             </a:pPr>
             <a:r>
-              <a:t>CaseProof checks evidence, policy, stage order, and review routing.</a:t>
+              <a:t>CaseProof checks evidence, policy, required milestones, and review routing.</a:t>
             </a:r>
           </a:p>
           <a:p>
@@ -3290,7 +3290,7 @@
               <a:defRPr sz="2300"/>
             </a:pPr>
             <a:r>
-              <a:t>A case can look complete while key evidence is missing.</a:t>
+              <a:t>A refund case can look complete while delivery proof or a customer statement is missing.</a:t>
             </a:r>
           </a:p>
           <a:p>
@@ -3301,7 +3301,7 @@
               <a:defRPr sz="2300"/>
             </a:pPr>
             <a:r>
-              <a:t>An agent can skip a policy step or reuse the wrong rationale.</a:t>
+              <a:t>An agent can skip policy or risk review.</a:t>
             </a:r>
           </a:p>
           <a:p>
@@ -3312,7 +3312,7 @@
               <a:defRPr sz="2300"/>
             </a:pPr>
             <a:r>
-              <a:t>A high-value action can be routed as if it were low risk.</a:t>
+              <a:t>A high-value refund can be routed as if it were low risk.</a:t>
             </a:r>
           </a:p>
         </p:txBody>
@@ -3417,7 +3417,7 @@
               <a:defRPr sz="2300"/>
             </a:pPr>
             <a:r>
-              <a:t>Maestro stages appear in the required order.</a:t>
+              <a:t>Required Maestro case milestones are present.</a:t>
             </a:r>
           </a:p>
           <a:p>
@@ -3511,7 +3511,7 @@
               <a:defRPr sz="2300"/>
             </a:pPr>
             <a:r>
-              <a:t>HOLD: evidence is missing.</a:t>
+              <a:t>HOLD: refund evidence is missing.</a:t>
             </a:r>
           </a:p>
           <a:p>
@@ -3533,7 +3533,7 @@
               <a:defRPr sz="2300"/>
             </a:pPr>
             <a:r>
-              <a:t>BLOCK: policy bypass or skipped stage.</a:t>
+              <a:t>BLOCK: policy bypass or skipped milestone.</a:t>
             </a:r>
           </a:p>
           <a:p>

</xml_diff>